<commit_message>
Migrate to standalone Node.js, PostgreSQL and email authentication
</commit_message>
<xml_diff>
--- a/docs/QorAI-Idea-Battle.pptx
+++ b/docs/QorAI-Idea-Battle.pptx
@@ -2,22 +2,22 @@
 <file path=ppt/presentation.xml><?xml version="1.0" encoding="utf-8"?>
 <p:presentation xmlns:p="http://schemas.openxmlformats.org/presentationml/2006/main">
   <p:sldMasterIdLst>
-    <p:sldMasterId xmlns:r="http://schemas.openxmlformats.org/officeDocument/2006/relationships" id="2147483648" r:id="Re9249e6ca72e4ba0"/>
+    <p:sldMasterId xmlns:r="http://schemas.openxmlformats.org/officeDocument/2006/relationships" id="2147483648" r:id="Re4eb98fb8cc442a4"/>
   </p:sldMasterIdLst>
   <p:notesMasterIdLst>
-    <p:notesMasterId xmlns:r="http://schemas.openxmlformats.org/officeDocument/2006/relationships" r:id="R376dac87d9f14b78"/>
+    <p:notesMasterId xmlns:r="http://schemas.openxmlformats.org/officeDocument/2006/relationships" r:id="R1812eda35fd047fa"/>
   </p:notesMasterIdLst>
   <p:sldIdLst>
-    <p:sldId xmlns:r="http://schemas.openxmlformats.org/officeDocument/2006/relationships" id="256" r:id="R1f7fcd71650c4934"/>
-    <p:sldId xmlns:r="http://schemas.openxmlformats.org/officeDocument/2006/relationships" id="257" r:id="R009c443a023345df"/>
-    <p:sldId xmlns:r="http://schemas.openxmlformats.org/officeDocument/2006/relationships" id="258" r:id="Rb81f9657c3df48d0"/>
-    <p:sldId xmlns:r="http://schemas.openxmlformats.org/officeDocument/2006/relationships" id="259" r:id="Rabdb852f40564e3a"/>
-    <p:sldId xmlns:r="http://schemas.openxmlformats.org/officeDocument/2006/relationships" id="260" r:id="R50b96f92114242e2"/>
-    <p:sldId xmlns:r="http://schemas.openxmlformats.org/officeDocument/2006/relationships" id="261" r:id="R37a5e0ff810e48a5"/>
-    <p:sldId xmlns:r="http://schemas.openxmlformats.org/officeDocument/2006/relationships" id="262" r:id="R439ffbd2823745c5"/>
-    <p:sldId xmlns:r="http://schemas.openxmlformats.org/officeDocument/2006/relationships" id="263" r:id="R40333ec326004bdb"/>
-    <p:sldId xmlns:r="http://schemas.openxmlformats.org/officeDocument/2006/relationships" id="264" r:id="R94f9d9d2832a4b1d"/>
-    <p:sldId xmlns:r="http://schemas.openxmlformats.org/officeDocument/2006/relationships" id="265" r:id="Re4358ef50bf6495c"/>
+    <p:sldId xmlns:r="http://schemas.openxmlformats.org/officeDocument/2006/relationships" id="256" r:id="R710ca99cb2314989"/>
+    <p:sldId xmlns:r="http://schemas.openxmlformats.org/officeDocument/2006/relationships" id="257" r:id="R68a46794254048cf"/>
+    <p:sldId xmlns:r="http://schemas.openxmlformats.org/officeDocument/2006/relationships" id="258" r:id="R83db7d1a493a4de6"/>
+    <p:sldId xmlns:r="http://schemas.openxmlformats.org/officeDocument/2006/relationships" id="259" r:id="Rcf88bac8d49e44c6"/>
+    <p:sldId xmlns:r="http://schemas.openxmlformats.org/officeDocument/2006/relationships" id="260" r:id="R5a184b5a3f994868"/>
+    <p:sldId xmlns:r="http://schemas.openxmlformats.org/officeDocument/2006/relationships" id="261" r:id="R4f940690bed84802"/>
+    <p:sldId xmlns:r="http://schemas.openxmlformats.org/officeDocument/2006/relationships" id="262" r:id="Re68e640086ca44e4"/>
+    <p:sldId xmlns:r="http://schemas.openxmlformats.org/officeDocument/2006/relationships" id="263" r:id="Rda3ca9e62554463d"/>
+    <p:sldId xmlns:r="http://schemas.openxmlformats.org/officeDocument/2006/relationships" id="264" r:id="Ra8d85ebb4eee40f8"/>
+    <p:sldId xmlns:r="http://schemas.openxmlformats.org/officeDocument/2006/relationships" id="265" r:id="R0ecf7bf74c354808"/>
   </p:sldIdLst>
   <p:sldSz cx="12192000" cy="6858000"/>
   <p:notesSz cx="6858000" cy="9144000"/>
@@ -556,7 +556,7 @@
           </a:p>
           <a:p xmlns:a="http://schemas.openxmlformats.org/drawingml/2006/main">
             <a:r>
-              <a:t>Сейчас у нас есть публичный сайт с демонстрацией, склад с сохранением данных, история операций, план закупок и контакты поставщиков с переходом в мессенджеры. Следующий шаг — три пилотные точки в Таразе. Ищем владельцев, с которыми сможем проверить сценарий на реальных приходах и продажах. Откройте демонстрацию по ссылке на экране. Спасибо! Мы команда QorAI.</a:t>
+              <a:t>Сейчас у нас есть публичный сайт с демонстрацией, склад с сохранением данных, история операций, план закупок и контакты поставщиков с переходом в мессенджеры. Следующий шаг — три пилотные точки в Таразе. Ищем владельцев, с которыми сможем проверить сценарий на реальных приходах и продажах. Откройте репозиторий по ссылке на экране: в нём есть ссылка на демонстрацию. Спасибо! Мы команда QorAI.</a:t>
             </a:r>
           </a:p>
           <a:p xmlns:a="http://schemas.openxmlformats.org/drawingml/2006/main">
@@ -931,7 +931,7 @@
           </a:p>
           <a:p xmlns:a="http://schemas.openxmlformats.org/drawingml/2006/main">
             <a:r>
-              <a:t>Расчёт спроса в исходниках: src/lib/domain.ts. Поправки на погоду и выходные не являются обученной ML-моделью. Экономия не измерена.</a:t>
+              <a:t>Расчёт спроса в исходниках: lib/domain.ts. Поправки на погоду и выходные не являются обученной ML-моделью. Экономия не измерена.</a:t>
             </a:r>
           </a:p>
         </p:txBody>
@@ -1333,7 +1333,7 @@
           <p:cNvPr id="3" name="Title">
             <a:extLst xmlns:a="http://schemas.openxmlformats.org/drawingml/2006/main">
               <a:ext uri="{FF2B5EF4-FFF2-40B4-BE49-F238E27FC236}">
-                <a16:creationId xmlns:a16="http://schemas.microsoft.com/office/drawing/2014/main" id="{85FAF772-43C3-40EC-973F-D5BCE1CF7897}"/>
+                <a16:creationId xmlns:a16="http://schemas.microsoft.com/office/drawing/2014/main" id="{D74BDABC-A6DF-4F71-974B-44C96594390C}"/>
               </a:ext>
             </a:extLst>
           </p:cNvPr>
@@ -1490,7 +1490,7 @@
           <p:cNvPr id="2" name="Subtitle">
             <a:extLst xmlns:a="http://schemas.openxmlformats.org/drawingml/2006/main">
               <a:ext uri="{FF2B5EF4-FFF2-40B4-BE49-F238E27FC236}">
-                <a16:creationId xmlns:a16="http://schemas.microsoft.com/office/drawing/2014/main" id="{664B1038-12CE-4A07-8020-82D7E99F623D}"/>
+                <a16:creationId xmlns:a16="http://schemas.microsoft.com/office/drawing/2014/main" id="{F31128AB-C304-42A7-A4B9-7129B742A8ED}"/>
               </a:ext>
             </a:extLst>
           </p:cNvPr>
@@ -1664,7 +1664,7 @@
           <p:cNvPr id="2" name="Section title">
             <a:extLst xmlns:a="http://schemas.openxmlformats.org/drawingml/2006/main">
               <a:ext uri="{FF2B5EF4-FFF2-40B4-BE49-F238E27FC236}">
-                <a16:creationId xmlns:a16="http://schemas.microsoft.com/office/drawing/2014/main" id="{23AAC2A1-6519-4EE8-9661-A8848844EB38}"/>
+                <a16:creationId xmlns:a16="http://schemas.microsoft.com/office/drawing/2014/main" id="{CD712041-8CC1-4276-B4C3-1A1910B240FD}"/>
               </a:ext>
             </a:extLst>
           </p:cNvPr>
@@ -1838,7 +1838,7 @@
           <p:cNvPr id="3" name="Title">
             <a:extLst xmlns:a="http://schemas.openxmlformats.org/drawingml/2006/main">
               <a:ext uri="{FF2B5EF4-FFF2-40B4-BE49-F238E27FC236}">
-                <a16:creationId xmlns:a16="http://schemas.microsoft.com/office/drawing/2014/main" id="{B8A19BC0-9B5E-4944-8E30-AAD8559EBAFC}"/>
+                <a16:creationId xmlns:a16="http://schemas.microsoft.com/office/drawing/2014/main" id="{E4EFF15F-64BE-45FD-807D-CB7F2403D36B}"/>
               </a:ext>
             </a:extLst>
           </p:cNvPr>
@@ -1995,7 +1995,7 @@
           <p:cNvPr id="2" name="Body">
             <a:extLst xmlns:a="http://schemas.openxmlformats.org/drawingml/2006/main">
               <a:ext uri="{FF2B5EF4-FFF2-40B4-BE49-F238E27FC236}">
-                <a16:creationId xmlns:a16="http://schemas.microsoft.com/office/drawing/2014/main" id="{2FCB1E4D-855A-46DB-BB63-A8D36B46D353}"/>
+                <a16:creationId xmlns:a16="http://schemas.microsoft.com/office/drawing/2014/main" id="{09363158-D659-447A-BAF7-C5B5603F9457}"/>
               </a:ext>
             </a:extLst>
           </p:cNvPr>
@@ -2169,7 +2169,7 @@
           <p:cNvPr id="4" name="Title">
             <a:extLst xmlns:a="http://schemas.openxmlformats.org/drawingml/2006/main">
               <a:ext uri="{FF2B5EF4-FFF2-40B4-BE49-F238E27FC236}">
-                <a16:creationId xmlns:a16="http://schemas.microsoft.com/office/drawing/2014/main" id="{4F8ADF0A-D189-4DC5-A612-1BBB4DB5F495}"/>
+                <a16:creationId xmlns:a16="http://schemas.microsoft.com/office/drawing/2014/main" id="{55067A46-74F0-4F47-B6BF-256A61B7981A}"/>
               </a:ext>
             </a:extLst>
           </p:cNvPr>
@@ -2326,7 +2326,7 @@
           <p:cNvPr id="2" name="Left column">
             <a:extLst xmlns:a="http://schemas.openxmlformats.org/drawingml/2006/main">
               <a:ext uri="{FF2B5EF4-FFF2-40B4-BE49-F238E27FC236}">
-                <a16:creationId xmlns:a16="http://schemas.microsoft.com/office/drawing/2014/main" id="{30F13DA3-8AA7-45E9-814F-492240292F6D}"/>
+                <a16:creationId xmlns:a16="http://schemas.microsoft.com/office/drawing/2014/main" id="{6147C793-751A-444C-AF37-4B721BD63C43}"/>
               </a:ext>
             </a:extLst>
           </p:cNvPr>
@@ -2483,7 +2483,7 @@
           <p:cNvPr id="3" name="Right column">
             <a:extLst xmlns:a="http://schemas.openxmlformats.org/drawingml/2006/main">
               <a:ext uri="{FF2B5EF4-FFF2-40B4-BE49-F238E27FC236}">
-                <a16:creationId xmlns:a16="http://schemas.microsoft.com/office/drawing/2014/main" id="{BE76B2E9-9C27-4E04-9069-0D24E286BA29}"/>
+                <a16:creationId xmlns:a16="http://schemas.microsoft.com/office/drawing/2014/main" id="{AE93E5DF-40E4-4805-B075-3651D0DEC80B}"/>
               </a:ext>
             </a:extLst>
           </p:cNvPr>
@@ -2657,7 +2657,7 @@
           <p:cNvPr id="3" name="Title">
             <a:extLst xmlns:a="http://schemas.openxmlformats.org/drawingml/2006/main">
               <a:ext uri="{FF2B5EF4-FFF2-40B4-BE49-F238E27FC236}">
-                <a16:creationId xmlns:a16="http://schemas.microsoft.com/office/drawing/2014/main" id="{90597E9A-D85A-4D9B-822E-AC7EB4D7770A}"/>
+                <a16:creationId xmlns:a16="http://schemas.microsoft.com/office/drawing/2014/main" id="{33CB47B6-E4EA-439E-8C1E-F6F142370426}"/>
               </a:ext>
             </a:extLst>
           </p:cNvPr>
@@ -2814,7 +2814,7 @@
           <p:cNvPr id="2" name="Left column">
             <a:extLst xmlns:a="http://schemas.openxmlformats.org/drawingml/2006/main">
               <a:ext uri="{FF2B5EF4-FFF2-40B4-BE49-F238E27FC236}">
-                <a16:creationId xmlns:a16="http://schemas.microsoft.com/office/drawing/2014/main" id="{5809051F-19BF-48CB-9F63-712799CFC338}"/>
+                <a16:creationId xmlns:a16="http://schemas.microsoft.com/office/drawing/2014/main" id="{BF8F5488-8CBC-4CF4-98A2-395D732164B8}"/>
               </a:ext>
             </a:extLst>
           </p:cNvPr>
@@ -3009,12 +3009,12 @@
   </p:cSld>
   <p:clrMap bg1="lt1" tx1="dk1" bg2="lt2" tx2="dk2" accent1="accent1" accent2="accent2" accent3="accent3" accent4="accent4" accent5="accent5" accent6="accent6" hlink="hlink" folHlink="folHlink"/>
   <p:sldLayoutIdLst>
-    <p:sldLayoutId xmlns:r="http://schemas.openxmlformats.org/officeDocument/2006/relationships" id="2147483649" r:id="R84ba9c0873704f20"/>
-    <p:sldLayoutId xmlns:r="http://schemas.openxmlformats.org/officeDocument/2006/relationships" id="2147483650" r:id="R0cfa4a4f32e34cd0"/>
-    <p:sldLayoutId xmlns:r="http://schemas.openxmlformats.org/officeDocument/2006/relationships" id="2147483651" r:id="Rdba0e7151386471f"/>
-    <p:sldLayoutId xmlns:r="http://schemas.openxmlformats.org/officeDocument/2006/relationships" id="2147483652" r:id="Rb8a7be30f6da47b2"/>
-    <p:sldLayoutId xmlns:r="http://schemas.openxmlformats.org/officeDocument/2006/relationships" id="2147483653" r:id="R8da053bd8b03461c"/>
-    <p:sldLayoutId xmlns:r="http://schemas.openxmlformats.org/officeDocument/2006/relationships" id="2147483654" r:id="R755c41e450734435"/>
+    <p:sldLayoutId xmlns:r="http://schemas.openxmlformats.org/officeDocument/2006/relationships" id="2147483649" r:id="Rc6a8de6f23a34c66"/>
+    <p:sldLayoutId xmlns:r="http://schemas.openxmlformats.org/officeDocument/2006/relationships" id="2147483650" r:id="R7f53302939a0440d"/>
+    <p:sldLayoutId xmlns:r="http://schemas.openxmlformats.org/officeDocument/2006/relationships" id="2147483651" r:id="Rb1211b0cfd30488c"/>
+    <p:sldLayoutId xmlns:r="http://schemas.openxmlformats.org/officeDocument/2006/relationships" id="2147483652" r:id="Rd4b2ec1ed01e4217"/>
+    <p:sldLayoutId xmlns:r="http://schemas.openxmlformats.org/officeDocument/2006/relationships" id="2147483653" r:id="R76ed8953482848cc"/>
+    <p:sldLayoutId xmlns:r="http://schemas.openxmlformats.org/officeDocument/2006/relationships" id="2147483654" r:id="R5524a1028ea54cd8"/>
   </p:sldLayoutIdLst>
   <p:txStyles>
     <p:titleStyle>
@@ -3565,7 +3565,7 @@
           <p:cNvPr id="7" name="">
             <a:extLst xmlns:a="http://schemas.openxmlformats.org/drawingml/2006/main">
               <a:ext uri="{FF2B5EF4-FFF2-40B4-BE49-F238E27FC236}">
-                <a16:creationId xmlns:a16="http://schemas.microsoft.com/office/drawing/2014/main" id="{1922F5AB-5BC9-4156-8AAE-4F02DE7FCCA1}"/>
+                <a16:creationId xmlns:a16="http://schemas.microsoft.com/office/drawing/2014/main" id="{3B13C1C0-E43C-40EA-893D-339C684D5A01}"/>
               </a:ext>
             </a:extLst>
           </p:cNvPr>
@@ -3575,7 +3575,7 @@
           <p:nvPr/>
         </p:nvPicPr>
         <p:blipFill>
-          <a:blip xmlns:r="http://schemas.openxmlformats.org/officeDocument/2006/relationships" xmlns:a="http://schemas.openxmlformats.org/drawingml/2006/main" r:embed="Rd9e41e2e87ed43a9"/>
+          <a:blip xmlns:r="http://schemas.openxmlformats.org/officeDocument/2006/relationships" xmlns:a="http://schemas.openxmlformats.org/drawingml/2006/main" r:embed="R468b3bf60519471e"/>
           <a:srcRect xmlns:a="http://schemas.openxmlformats.org/drawingml/2006/main" l="30000" t="0" r="5000" b="0"/>
           <a:stretch xmlns:a="http://schemas.openxmlformats.org/drawingml/2006/main"/>
         </p:blipFill>
@@ -3594,7 +3594,7 @@
           <p:cNvPr id="2" name="">
             <a:extLst xmlns:a="http://schemas.openxmlformats.org/drawingml/2006/main">
               <a:ext uri="{FF2B5EF4-FFF2-40B4-BE49-F238E27FC236}">
-                <a16:creationId xmlns:a16="http://schemas.microsoft.com/office/drawing/2014/main" id="{1CEE1F10-9BE2-4649-BB53-65F435DE8911}"/>
+                <a16:creationId xmlns:a16="http://schemas.microsoft.com/office/drawing/2014/main" id="{14A7D8D3-0B06-4C64-B119-9638B2F75734}"/>
               </a:ext>
             </a:extLst>
           </p:cNvPr>
@@ -3660,7 +3660,7 @@
           <p:cNvPr id="3" name="">
             <a:extLst xmlns:a="http://schemas.openxmlformats.org/drawingml/2006/main">
               <a:ext uri="{FF2B5EF4-FFF2-40B4-BE49-F238E27FC236}">
-                <a16:creationId xmlns:a16="http://schemas.microsoft.com/office/drawing/2014/main" id="{23A78FEF-0C62-4608-B2E8-19359B5BDBCE}"/>
+                <a16:creationId xmlns:a16="http://schemas.microsoft.com/office/drawing/2014/main" id="{D55CA879-2741-4AC0-8CFE-EB4BB17C618D}"/>
               </a:ext>
             </a:extLst>
           </p:cNvPr>
@@ -3726,7 +3726,7 @@
           <p:cNvPr id="4" name="">
             <a:extLst xmlns:a="http://schemas.openxmlformats.org/drawingml/2006/main">
               <a:ext uri="{FF2B5EF4-FFF2-40B4-BE49-F238E27FC236}">
-                <a16:creationId xmlns:a16="http://schemas.microsoft.com/office/drawing/2014/main" id="{1C751980-FA12-4851-90B8-35C14123787B}"/>
+                <a16:creationId xmlns:a16="http://schemas.microsoft.com/office/drawing/2014/main" id="{B970D394-CA80-4658-8114-81D339E51B53}"/>
               </a:ext>
             </a:extLst>
           </p:cNvPr>
@@ -3815,7 +3815,7 @@
           <p:cNvPr id="5" name="">
             <a:extLst xmlns:a="http://schemas.openxmlformats.org/drawingml/2006/main">
               <a:ext uri="{FF2B5EF4-FFF2-40B4-BE49-F238E27FC236}">
-                <a16:creationId xmlns:a16="http://schemas.microsoft.com/office/drawing/2014/main" id="{4F5156B1-F924-4B4B-AA6C-8153D4FD4D2C}"/>
+                <a16:creationId xmlns:a16="http://schemas.microsoft.com/office/drawing/2014/main" id="{488DFB55-F32F-4F2B-9DEF-C60410C7033E}"/>
               </a:ext>
             </a:extLst>
           </p:cNvPr>
@@ -3904,7 +3904,7 @@
           <p:cNvPr id="6" name="">
             <a:extLst xmlns:a="http://schemas.openxmlformats.org/drawingml/2006/main">
               <a:ext uri="{FF2B5EF4-FFF2-40B4-BE49-F238E27FC236}">
-                <a16:creationId xmlns:a16="http://schemas.microsoft.com/office/drawing/2014/main" id="{82C4D9D4-3013-42DE-8AC4-946542AF0CAF}"/>
+                <a16:creationId xmlns:a16="http://schemas.microsoft.com/office/drawing/2014/main" id="{714E1225-655C-45F3-B29A-0C244F9D1494}"/>
               </a:ext>
             </a:extLst>
           </p:cNvPr>
@@ -3968,7 +3968,7 @@
     </p:spTree>
     <p:extLst>
       <p:ext uri="{BB962C8B-B14F-4D97-AF65-F5344CB8AC3E}">
-        <p14:creationId xmlns:p14="http://schemas.microsoft.com/office/powerpoint/2010/main" val="384529866"/>
+        <p14:creationId xmlns:p14="http://schemas.microsoft.com/office/powerpoint/2010/main" val="2039608609"/>
       </p:ext>
     </p:extLst>
   </p:cSld>
@@ -3999,7 +3999,7 @@
           <p:cNvPr id="8" name="">
             <a:extLst xmlns:a="http://schemas.openxmlformats.org/drawingml/2006/main">
               <a:ext uri="{FF2B5EF4-FFF2-40B4-BE49-F238E27FC236}">
-                <a16:creationId xmlns:a16="http://schemas.microsoft.com/office/drawing/2014/main" id="{A6F3ADF8-68ED-4116-AE38-322F8FD0332E}"/>
+                <a16:creationId xmlns:a16="http://schemas.microsoft.com/office/drawing/2014/main" id="{0C7326DE-51C4-4B20-A980-3C54AEA9DF4F}"/>
               </a:ext>
             </a:extLst>
           </p:cNvPr>
@@ -4065,7 +4065,7 @@
           <p:cNvPr id="2" name="">
             <a:extLst xmlns:a="http://schemas.openxmlformats.org/drawingml/2006/main">
               <a:ext uri="{FF2B5EF4-FFF2-40B4-BE49-F238E27FC236}">
-                <a16:creationId xmlns:a16="http://schemas.microsoft.com/office/drawing/2014/main" id="{9774AA4D-E28F-40AF-A64A-993F5CBAD57E}"/>
+                <a16:creationId xmlns:a16="http://schemas.microsoft.com/office/drawing/2014/main" id="{70B0DD51-1330-4CCA-A320-41EB7C5EA32C}"/>
               </a:ext>
             </a:extLst>
           </p:cNvPr>
@@ -4177,7 +4177,7 @@
           <p:cNvPr id="3" name="">
             <a:extLst xmlns:a="http://schemas.openxmlformats.org/drawingml/2006/main">
               <a:ext uri="{FF2B5EF4-FFF2-40B4-BE49-F238E27FC236}">
-                <a16:creationId xmlns:a16="http://schemas.microsoft.com/office/drawing/2014/main" id="{D782E199-DF73-47D1-B5F2-BC171D86C3FD}"/>
+                <a16:creationId xmlns:a16="http://schemas.microsoft.com/office/drawing/2014/main" id="{EBC7EC14-830C-4359-ABC9-CB4761B6A353}"/>
               </a:ext>
             </a:extLst>
           </p:cNvPr>
@@ -4233,7 +4233,7 @@
                 <a:ea typeface="Liberation Sans"/>
                 <a:cs typeface="Liberation Sans"/>
               </a:rPr>
-              <a:t>Демо открыто для всех</a:t>
+              <a:t>Демо и исходники проекта</a:t>
             </a:r>
           </a:p>
         </p:txBody>
@@ -4243,7 +4243,7 @@
           <p:cNvPr id="4" name="">
             <a:extLst xmlns:a="http://schemas.openxmlformats.org/drawingml/2006/main">
               <a:ext uri="{FF2B5EF4-FFF2-40B4-BE49-F238E27FC236}">
-                <a16:creationId xmlns:a16="http://schemas.microsoft.com/office/drawing/2014/main" id="{44F1AC7A-6052-4484-A80F-3807FB6FA59B}"/>
+                <a16:creationId xmlns:a16="http://schemas.microsoft.com/office/drawing/2014/main" id="{E1A22E4F-114B-4789-A3C3-85BC8E265F1B}"/>
               </a:ext>
             </a:extLst>
           </p:cNvPr>
@@ -4299,7 +4299,7 @@
                 <a:ea typeface="Liberation Sans"/>
                 <a:cs typeface="Liberation Sans"/>
               </a:rPr>
-              <a:t>qorai-taraz.nursultantulegen11.chatgpt.site</a:t>
+              <a:t>github.com/nursultantulegen11-commits/qorai</a:t>
             </a:r>
           </a:p>
         </p:txBody>
@@ -4309,7 +4309,7 @@
           <p:cNvPr id="5" name="">
             <a:extLst xmlns:a="http://schemas.openxmlformats.org/drawingml/2006/main">
               <a:ext uri="{FF2B5EF4-FFF2-40B4-BE49-F238E27FC236}">
-                <a16:creationId xmlns:a16="http://schemas.microsoft.com/office/drawing/2014/main" id="{64FC9B93-A6E9-4767-8CDC-157FEA414CCD}"/>
+                <a16:creationId xmlns:a16="http://schemas.microsoft.com/office/drawing/2014/main" id="{F26DF66C-7722-423A-B809-848E038B2BA6}"/>
               </a:ext>
             </a:extLst>
           </p:cNvPr>
@@ -4398,7 +4398,7 @@
           <p:cNvPr id="6" name="">
             <a:extLst xmlns:a="http://schemas.openxmlformats.org/drawingml/2006/main">
               <a:ext uri="{FF2B5EF4-FFF2-40B4-BE49-F238E27FC236}">
-                <a16:creationId xmlns:a16="http://schemas.microsoft.com/office/drawing/2014/main" id="{C6B5C768-F31C-4433-8477-1A9E849AB449}"/>
+                <a16:creationId xmlns:a16="http://schemas.microsoft.com/office/drawing/2014/main" id="{5C8157C9-6F16-46A2-B9DC-09CE7C70D6C8}"/>
               </a:ext>
             </a:extLst>
           </p:cNvPr>
@@ -4408,7 +4408,7 @@
           <p:nvPr/>
         </p:nvPicPr>
         <p:blipFill>
-          <a:blip xmlns:r="http://schemas.openxmlformats.org/officeDocument/2006/relationships" xmlns:a="http://schemas.openxmlformats.org/drawingml/2006/main" r:embed="R8112e4b8374246b0"/>
+          <a:blip xmlns:r="http://schemas.openxmlformats.org/officeDocument/2006/relationships" xmlns:a="http://schemas.openxmlformats.org/drawingml/2006/main" r:embed="Rff73d5be8d35464c"/>
           <a:srcRect xmlns:a="http://schemas.openxmlformats.org/drawingml/2006/main" l="19000" t="7500" r="2000" b="4000"/>
           <a:stretch xmlns:a="http://schemas.openxmlformats.org/drawingml/2006/main"/>
         </p:blipFill>
@@ -4427,7 +4427,7 @@
           <p:cNvPr id="7" name="">
             <a:extLst xmlns:a="http://schemas.openxmlformats.org/drawingml/2006/main">
               <a:ext uri="{FF2B5EF4-FFF2-40B4-BE49-F238E27FC236}">
-                <a16:creationId xmlns:a16="http://schemas.microsoft.com/office/drawing/2014/main" id="{1A488AEC-19A5-4266-96F5-5CFD845B18EB}"/>
+                <a16:creationId xmlns:a16="http://schemas.microsoft.com/office/drawing/2014/main" id="{7A72FB22-8452-4AD3-92C6-C6F310FF9BC3}"/>
               </a:ext>
             </a:extLst>
           </p:cNvPr>
@@ -4491,7 +4491,7 @@
     </p:spTree>
     <p:extLst>
       <p:ext uri="{BB962C8B-B14F-4D97-AF65-F5344CB8AC3E}">
-        <p14:creationId xmlns:p14="http://schemas.microsoft.com/office/powerpoint/2010/main" val="736211834"/>
+        <p14:creationId xmlns:p14="http://schemas.microsoft.com/office/powerpoint/2010/main" val="189028034"/>
       </p:ext>
     </p:extLst>
   </p:cSld>
@@ -4522,7 +4522,7 @@
           <p:cNvPr id="7" name="">
             <a:extLst xmlns:a="http://schemas.openxmlformats.org/drawingml/2006/main">
               <a:ext uri="{FF2B5EF4-FFF2-40B4-BE49-F238E27FC236}">
-                <a16:creationId xmlns:a16="http://schemas.microsoft.com/office/drawing/2014/main" id="{B65D9887-28F2-4881-BBA7-00D779580CC6}"/>
+                <a16:creationId xmlns:a16="http://schemas.microsoft.com/office/drawing/2014/main" id="{732A434C-DF72-4773-A7E7-3BFD48026D8B}"/>
               </a:ext>
             </a:extLst>
           </p:cNvPr>
@@ -4532,7 +4532,7 @@
           <p:nvPr/>
         </p:nvPicPr>
         <p:blipFill>
-          <a:blip xmlns:r="http://schemas.openxmlformats.org/officeDocument/2006/relationships" xmlns:a="http://schemas.openxmlformats.org/drawingml/2006/main" r:embed="Rd2db8592f9e2483a"/>
+          <a:blip xmlns:r="http://schemas.openxmlformats.org/officeDocument/2006/relationships" xmlns:a="http://schemas.openxmlformats.org/drawingml/2006/main" r:embed="Rb98a98dccd164c23"/>
           <a:srcRect xmlns:a="http://schemas.openxmlformats.org/drawingml/2006/main" l="14000" t="0" r="20000" b="0"/>
           <a:stretch xmlns:a="http://schemas.openxmlformats.org/drawingml/2006/main"/>
         </p:blipFill>
@@ -4551,7 +4551,7 @@
           <p:cNvPr id="2" name="">
             <a:extLst xmlns:a="http://schemas.openxmlformats.org/drawingml/2006/main">
               <a:ext uri="{FF2B5EF4-FFF2-40B4-BE49-F238E27FC236}">
-                <a16:creationId xmlns:a16="http://schemas.microsoft.com/office/drawing/2014/main" id="{0CD6EB52-0CC6-41CE-AF87-932C9EAE0A4B}"/>
+                <a16:creationId xmlns:a16="http://schemas.microsoft.com/office/drawing/2014/main" id="{D952F0A8-DC19-4522-98C3-D0EAF9C361C1}"/>
               </a:ext>
             </a:extLst>
           </p:cNvPr>
@@ -4663,7 +4663,7 @@
           <p:cNvPr id="3" name="">
             <a:extLst xmlns:a="http://schemas.openxmlformats.org/drawingml/2006/main">
               <a:ext uri="{FF2B5EF4-FFF2-40B4-BE49-F238E27FC236}">
-                <a16:creationId xmlns:a16="http://schemas.microsoft.com/office/drawing/2014/main" id="{BF28F64C-1D35-454C-AC15-A5F4C5C09A2E}"/>
+                <a16:creationId xmlns:a16="http://schemas.microsoft.com/office/drawing/2014/main" id="{13BA992A-95D4-4D2C-BF95-6F51DBDA52B8}"/>
               </a:ext>
             </a:extLst>
           </p:cNvPr>
@@ -4785,7 +4785,7 @@
           <p:cNvPr id="4" name="">
             <a:extLst xmlns:a="http://schemas.openxmlformats.org/drawingml/2006/main">
               <a:ext uri="{FF2B5EF4-FFF2-40B4-BE49-F238E27FC236}">
-                <a16:creationId xmlns:a16="http://schemas.microsoft.com/office/drawing/2014/main" id="{32AB8B75-D700-43B1-AF08-F862EF6C21CD}"/>
+                <a16:creationId xmlns:a16="http://schemas.microsoft.com/office/drawing/2014/main" id="{FA9A1DB2-5C16-4F71-9990-E4F073878299}"/>
               </a:ext>
             </a:extLst>
           </p:cNvPr>
@@ -4851,7 +4851,7 @@
           <p:cNvPr id="5" name="">
             <a:extLst xmlns:a="http://schemas.openxmlformats.org/drawingml/2006/main">
               <a:ext uri="{FF2B5EF4-FFF2-40B4-BE49-F238E27FC236}">
-                <a16:creationId xmlns:a16="http://schemas.microsoft.com/office/drawing/2014/main" id="{33238D30-4AC4-452B-A7F9-49B30E95892F}"/>
+                <a16:creationId xmlns:a16="http://schemas.microsoft.com/office/drawing/2014/main" id="{1326E907-7E9E-4B58-AD5F-D8F7052849D3}"/>
               </a:ext>
             </a:extLst>
           </p:cNvPr>
@@ -4917,7 +4917,7 @@
           <p:cNvPr id="6" name="">
             <a:extLst xmlns:a="http://schemas.openxmlformats.org/drawingml/2006/main">
               <a:ext uri="{FF2B5EF4-FFF2-40B4-BE49-F238E27FC236}">
-                <a16:creationId xmlns:a16="http://schemas.microsoft.com/office/drawing/2014/main" id="{F96A944E-920D-4105-9181-0E19F1D9CCC2}"/>
+                <a16:creationId xmlns:a16="http://schemas.microsoft.com/office/drawing/2014/main" id="{CE9E3B59-1D44-4060-840F-B8AF26551C1F}"/>
               </a:ext>
             </a:extLst>
           </p:cNvPr>
@@ -4981,7 +4981,7 @@
     </p:spTree>
     <p:extLst>
       <p:ext uri="{BB962C8B-B14F-4D97-AF65-F5344CB8AC3E}">
-        <p14:creationId xmlns:p14="http://schemas.microsoft.com/office/powerpoint/2010/main" val="1213761075"/>
+        <p14:creationId xmlns:p14="http://schemas.microsoft.com/office/powerpoint/2010/main" val="1001001814"/>
       </p:ext>
     </p:extLst>
   </p:cSld>
@@ -5012,7 +5012,7 @@
           <p:cNvPr id="7" name="">
             <a:extLst xmlns:a="http://schemas.openxmlformats.org/drawingml/2006/main">
               <a:ext uri="{FF2B5EF4-FFF2-40B4-BE49-F238E27FC236}">
-                <a16:creationId xmlns:a16="http://schemas.microsoft.com/office/drawing/2014/main" id="{D9FE1029-1AF1-40EE-99A8-3A9DBCF9941B}"/>
+                <a16:creationId xmlns:a16="http://schemas.microsoft.com/office/drawing/2014/main" id="{F941B7AC-A2BD-4583-A729-5674DA931971}"/>
               </a:ext>
             </a:extLst>
           </p:cNvPr>
@@ -5078,7 +5078,7 @@
           <p:cNvPr id="2" name="">
             <a:extLst xmlns:a="http://schemas.openxmlformats.org/drawingml/2006/main">
               <a:ext uri="{FF2B5EF4-FFF2-40B4-BE49-F238E27FC236}">
-                <a16:creationId xmlns:a16="http://schemas.microsoft.com/office/drawing/2014/main" id="{F7B9D48F-1D01-44BF-947F-4B757E9A2491}"/>
+                <a16:creationId xmlns:a16="http://schemas.microsoft.com/office/drawing/2014/main" id="{0923811B-B64F-4969-9544-43408F6245DE}"/>
               </a:ext>
             </a:extLst>
           </p:cNvPr>
@@ -5190,7 +5190,7 @@
           <p:cNvPr id="3" name="">
             <a:extLst xmlns:a="http://schemas.openxmlformats.org/drawingml/2006/main">
               <a:ext uri="{FF2B5EF4-FFF2-40B4-BE49-F238E27FC236}">
-                <a16:creationId xmlns:a16="http://schemas.microsoft.com/office/drawing/2014/main" id="{9FB2FC81-82D0-44B4-9CAD-99D079948800}"/>
+                <a16:creationId xmlns:a16="http://schemas.microsoft.com/office/drawing/2014/main" id="{FC39A3D5-9239-4369-9188-89377D46BE11}"/>
               </a:ext>
             </a:extLst>
           </p:cNvPr>
@@ -5302,7 +5302,7 @@
           <p:cNvPr id="4" name="">
             <a:extLst xmlns:a="http://schemas.openxmlformats.org/drawingml/2006/main">
               <a:ext uri="{FF2B5EF4-FFF2-40B4-BE49-F238E27FC236}">
-                <a16:creationId xmlns:a16="http://schemas.microsoft.com/office/drawing/2014/main" id="{E7985EE9-AC0F-46C2-BF07-BBF145C9722B}"/>
+                <a16:creationId xmlns:a16="http://schemas.microsoft.com/office/drawing/2014/main" id="{C776535D-C2C3-494B-9DD5-D56A8EFE303F}"/>
               </a:ext>
             </a:extLst>
           </p:cNvPr>
@@ -5312,7 +5312,7 @@
           <p:nvPr/>
         </p:nvPicPr>
         <p:blipFill>
-          <a:blip xmlns:r="http://schemas.openxmlformats.org/officeDocument/2006/relationships" xmlns:a="http://schemas.openxmlformats.org/drawingml/2006/main" r:embed="R4e5970df815c43a6"/>
+          <a:blip xmlns:r="http://schemas.openxmlformats.org/officeDocument/2006/relationships" xmlns:a="http://schemas.openxmlformats.org/drawingml/2006/main" r:embed="R7409ab4f5fa24e31"/>
           <a:srcRect xmlns:a="http://schemas.openxmlformats.org/drawingml/2006/main" l="0" t="4500" r="0" b="46000"/>
           <a:stretch xmlns:a="http://schemas.openxmlformats.org/drawingml/2006/main"/>
         </p:blipFill>
@@ -5331,7 +5331,7 @@
           <p:cNvPr id="5" name="">
             <a:extLst xmlns:a="http://schemas.openxmlformats.org/drawingml/2006/main">
               <a:ext uri="{FF2B5EF4-FFF2-40B4-BE49-F238E27FC236}">
-                <a16:creationId xmlns:a16="http://schemas.microsoft.com/office/drawing/2014/main" id="{F4A7D750-FC18-4ACD-B841-5E8EF43B67C4}"/>
+                <a16:creationId xmlns:a16="http://schemas.microsoft.com/office/drawing/2014/main" id="{2C498159-CCB6-4C07-8E8C-2FB556178679}"/>
               </a:ext>
             </a:extLst>
           </p:cNvPr>
@@ -5397,7 +5397,7 @@
           <p:cNvPr id="6" name="">
             <a:extLst xmlns:a="http://schemas.openxmlformats.org/drawingml/2006/main">
               <a:ext uri="{FF2B5EF4-FFF2-40B4-BE49-F238E27FC236}">
-                <a16:creationId xmlns:a16="http://schemas.microsoft.com/office/drawing/2014/main" id="{85A4108C-053B-4516-B4E4-4B5984F38B1E}"/>
+                <a16:creationId xmlns:a16="http://schemas.microsoft.com/office/drawing/2014/main" id="{230E175E-F0CF-4238-8EE0-DBC83B098228}"/>
               </a:ext>
             </a:extLst>
           </p:cNvPr>
@@ -5461,7 +5461,7 @@
     </p:spTree>
     <p:extLst>
       <p:ext uri="{BB962C8B-B14F-4D97-AF65-F5344CB8AC3E}">
-        <p14:creationId xmlns:p14="http://schemas.microsoft.com/office/powerpoint/2010/main" val="1953414228"/>
+        <p14:creationId xmlns:p14="http://schemas.microsoft.com/office/powerpoint/2010/main" val="651616713"/>
       </p:ext>
     </p:extLst>
   </p:cSld>
@@ -5492,7 +5492,7 @@
           <p:cNvPr id="10" name="">
             <a:extLst xmlns:a="http://schemas.openxmlformats.org/drawingml/2006/main">
               <a:ext uri="{FF2B5EF4-FFF2-40B4-BE49-F238E27FC236}">
-                <a16:creationId xmlns:a16="http://schemas.microsoft.com/office/drawing/2014/main" id="{27421E1E-3EBE-4A74-9245-93862A5CFA04}"/>
+                <a16:creationId xmlns:a16="http://schemas.microsoft.com/office/drawing/2014/main" id="{CF2049EB-71C8-4845-B6A5-38670E14EA26}"/>
               </a:ext>
             </a:extLst>
           </p:cNvPr>
@@ -5558,7 +5558,7 @@
           <p:cNvPr id="2" name="">
             <a:extLst xmlns:a="http://schemas.openxmlformats.org/drawingml/2006/main">
               <a:ext uri="{FF2B5EF4-FFF2-40B4-BE49-F238E27FC236}">
-                <a16:creationId xmlns:a16="http://schemas.microsoft.com/office/drawing/2014/main" id="{9D261FB0-522D-4911-9634-78FCB658567F}"/>
+                <a16:creationId xmlns:a16="http://schemas.microsoft.com/office/drawing/2014/main" id="{CF0A16BA-EBA2-4475-B097-EAAF6D799820}"/>
               </a:ext>
             </a:extLst>
           </p:cNvPr>
@@ -5670,7 +5670,7 @@
           <p:cNvPr id="3" name="">
             <a:extLst xmlns:a="http://schemas.openxmlformats.org/drawingml/2006/main">
               <a:ext uri="{FF2B5EF4-FFF2-40B4-BE49-F238E27FC236}">
-                <a16:creationId xmlns:a16="http://schemas.microsoft.com/office/drawing/2014/main" id="{164C1E83-2C6B-4BA4-82EF-1647CC0399B6}"/>
+                <a16:creationId xmlns:a16="http://schemas.microsoft.com/office/drawing/2014/main" id="{46CD204E-F3C6-4D59-B445-6866C5C51835}"/>
               </a:ext>
             </a:extLst>
           </p:cNvPr>
@@ -5782,7 +5782,7 @@
           <p:cNvPr id="4" name="">
             <a:extLst xmlns:a="http://schemas.openxmlformats.org/drawingml/2006/main">
               <a:ext uri="{FF2B5EF4-FFF2-40B4-BE49-F238E27FC236}">
-                <a16:creationId xmlns:a16="http://schemas.microsoft.com/office/drawing/2014/main" id="{BB579632-3352-431B-8837-3B7CD31D9DCA}"/>
+                <a16:creationId xmlns:a16="http://schemas.microsoft.com/office/drawing/2014/main" id="{6C6C93DA-CDC3-4754-8671-7FFB58285C19}"/>
               </a:ext>
             </a:extLst>
           </p:cNvPr>
@@ -5848,7 +5848,7 @@
           <p:cNvPr id="5" name="">
             <a:extLst xmlns:a="http://schemas.openxmlformats.org/drawingml/2006/main">
               <a:ext uri="{FF2B5EF4-FFF2-40B4-BE49-F238E27FC236}">
-                <a16:creationId xmlns:a16="http://schemas.microsoft.com/office/drawing/2014/main" id="{F8930CE5-07D8-4E18-B774-D39CCC4FD7E3}"/>
+                <a16:creationId xmlns:a16="http://schemas.microsoft.com/office/drawing/2014/main" id="{D9D7A68A-D8D0-4C8C-A4E0-DCDBAED8061F}"/>
               </a:ext>
             </a:extLst>
           </p:cNvPr>
@@ -5914,7 +5914,7 @@
           <p:cNvPr id="6" name="">
             <a:extLst xmlns:a="http://schemas.openxmlformats.org/drawingml/2006/main">
               <a:ext uri="{FF2B5EF4-FFF2-40B4-BE49-F238E27FC236}">
-                <a16:creationId xmlns:a16="http://schemas.microsoft.com/office/drawing/2014/main" id="{DC27F432-168A-4517-B324-70D1AE1852D6}"/>
+                <a16:creationId xmlns:a16="http://schemas.microsoft.com/office/drawing/2014/main" id="{3EEC1394-0437-4812-B5DD-3413B48B6C15}"/>
               </a:ext>
             </a:extLst>
           </p:cNvPr>
@@ -5924,7 +5924,7 @@
           <p:nvPr/>
         </p:nvPicPr>
         <p:blipFill>
-          <a:blip xmlns:r="http://schemas.openxmlformats.org/officeDocument/2006/relationships" xmlns:a="http://schemas.openxmlformats.org/drawingml/2006/main" r:embed="R8813e4597bbd4046"/>
+          <a:blip xmlns:r="http://schemas.openxmlformats.org/officeDocument/2006/relationships" xmlns:a="http://schemas.openxmlformats.org/drawingml/2006/main" r:embed="R544f874d5d374301"/>
           <a:srcRect xmlns:a="http://schemas.openxmlformats.org/drawingml/2006/main" l="2000" t="28000" r="2000" b="2000"/>
           <a:stretch xmlns:a="http://schemas.openxmlformats.org/drawingml/2006/main"/>
         </p:blipFill>
@@ -5943,7 +5943,7 @@
           <p:cNvPr id="7" name="">
             <a:extLst xmlns:a="http://schemas.openxmlformats.org/drawingml/2006/main">
               <a:ext uri="{FF2B5EF4-FFF2-40B4-BE49-F238E27FC236}">
-                <a16:creationId xmlns:a16="http://schemas.microsoft.com/office/drawing/2014/main" id="{E81C2364-28A2-40D1-8D46-0053FCF56607}"/>
+                <a16:creationId xmlns:a16="http://schemas.microsoft.com/office/drawing/2014/main" id="{C35BD5B3-735D-40E6-A73D-F72AC7DC8632}"/>
               </a:ext>
             </a:extLst>
           </p:cNvPr>
@@ -5953,7 +5953,7 @@
           <p:nvPr/>
         </p:nvPicPr>
         <p:blipFill>
-          <a:blip xmlns:r="http://schemas.openxmlformats.org/officeDocument/2006/relationships" xmlns:a="http://schemas.openxmlformats.org/drawingml/2006/main" r:embed="Rcaee248a0b5e4c7d"/>
+          <a:blip xmlns:r="http://schemas.openxmlformats.org/officeDocument/2006/relationships" xmlns:a="http://schemas.openxmlformats.org/drawingml/2006/main" r:embed="Rf5cdb73c16294ce3"/>
           <a:srcRect xmlns:a="http://schemas.openxmlformats.org/drawingml/2006/main" l="2000" t="5500" r="2000" b="2000"/>
           <a:stretch xmlns:a="http://schemas.openxmlformats.org/drawingml/2006/main"/>
         </p:blipFill>
@@ -5972,7 +5972,7 @@
           <p:cNvPr id="8" name="">
             <a:extLst xmlns:a="http://schemas.openxmlformats.org/drawingml/2006/main">
               <a:ext uri="{FF2B5EF4-FFF2-40B4-BE49-F238E27FC236}">
-                <a16:creationId xmlns:a16="http://schemas.microsoft.com/office/drawing/2014/main" id="{34EC0840-C0C1-4923-8637-C1F5F2CB461F}"/>
+                <a16:creationId xmlns:a16="http://schemas.microsoft.com/office/drawing/2014/main" id="{4802E9D7-19D1-46C0-ACC7-DF18B4437CE8}"/>
               </a:ext>
             </a:extLst>
           </p:cNvPr>
@@ -6038,7 +6038,7 @@
           <p:cNvPr id="9" name="">
             <a:extLst xmlns:a="http://schemas.openxmlformats.org/drawingml/2006/main">
               <a:ext uri="{FF2B5EF4-FFF2-40B4-BE49-F238E27FC236}">
-                <a16:creationId xmlns:a16="http://schemas.microsoft.com/office/drawing/2014/main" id="{C8781B96-D0D8-4BC9-896A-458246DBBA88}"/>
+                <a16:creationId xmlns:a16="http://schemas.microsoft.com/office/drawing/2014/main" id="{7C8DD731-0027-4F06-B57C-B3679B6E96AE}"/>
               </a:ext>
             </a:extLst>
           </p:cNvPr>
@@ -6102,7 +6102,7 @@
     </p:spTree>
     <p:extLst>
       <p:ext uri="{BB962C8B-B14F-4D97-AF65-F5344CB8AC3E}">
-        <p14:creationId xmlns:p14="http://schemas.microsoft.com/office/powerpoint/2010/main" val="100034931"/>
+        <p14:creationId xmlns:p14="http://schemas.microsoft.com/office/powerpoint/2010/main" val="1923458526"/>
       </p:ext>
     </p:extLst>
   </p:cSld>
@@ -6133,7 +6133,7 @@
           <p:cNvPr id="8" name="">
             <a:extLst xmlns:a="http://schemas.openxmlformats.org/drawingml/2006/main">
               <a:ext uri="{FF2B5EF4-FFF2-40B4-BE49-F238E27FC236}">
-                <a16:creationId xmlns:a16="http://schemas.microsoft.com/office/drawing/2014/main" id="{4BBFE6AF-A5FF-402B-AB27-E8B60C35ECD6}"/>
+                <a16:creationId xmlns:a16="http://schemas.microsoft.com/office/drawing/2014/main" id="{32ED808A-F308-42A6-BAD5-DB4E582E5DD1}"/>
               </a:ext>
             </a:extLst>
           </p:cNvPr>
@@ -6199,7 +6199,7 @@
           <p:cNvPr id="2" name="">
             <a:extLst xmlns:a="http://schemas.openxmlformats.org/drawingml/2006/main">
               <a:ext uri="{FF2B5EF4-FFF2-40B4-BE49-F238E27FC236}">
-                <a16:creationId xmlns:a16="http://schemas.microsoft.com/office/drawing/2014/main" id="{7744C825-5349-417C-921A-29D8560AAA0D}"/>
+                <a16:creationId xmlns:a16="http://schemas.microsoft.com/office/drawing/2014/main" id="{45B5BC73-9192-4557-97BC-188DA1D17ABA}"/>
               </a:ext>
             </a:extLst>
           </p:cNvPr>
@@ -6288,7 +6288,7 @@
           <p:cNvPr id="3" name="">
             <a:extLst xmlns:a="http://schemas.openxmlformats.org/drawingml/2006/main">
               <a:ext uri="{FF2B5EF4-FFF2-40B4-BE49-F238E27FC236}">
-                <a16:creationId xmlns:a16="http://schemas.microsoft.com/office/drawing/2014/main" id="{39290607-7C35-4412-A78E-C15478065A4E}"/>
+                <a16:creationId xmlns:a16="http://schemas.microsoft.com/office/drawing/2014/main" id="{E74CFD92-0938-4234-A454-949B3BDD974E}"/>
               </a:ext>
             </a:extLst>
           </p:cNvPr>
@@ -6400,7 +6400,7 @@
           <p:cNvPr id="4" name="">
             <a:extLst xmlns:a="http://schemas.openxmlformats.org/drawingml/2006/main">
               <a:ext uri="{FF2B5EF4-FFF2-40B4-BE49-F238E27FC236}">
-                <a16:creationId xmlns:a16="http://schemas.microsoft.com/office/drawing/2014/main" id="{1BB9860A-1825-4691-8978-516CDC8F7332}"/>
+                <a16:creationId xmlns:a16="http://schemas.microsoft.com/office/drawing/2014/main" id="{F97963A7-8AA7-49E3-89C8-9A7B82831A7E}"/>
               </a:ext>
             </a:extLst>
           </p:cNvPr>
@@ -6489,7 +6489,7 @@
           <p:cNvPr id="5" name="">
             <a:extLst xmlns:a="http://schemas.openxmlformats.org/drawingml/2006/main">
               <a:ext uri="{FF2B5EF4-FFF2-40B4-BE49-F238E27FC236}">
-                <a16:creationId xmlns:a16="http://schemas.microsoft.com/office/drawing/2014/main" id="{5B8E2A7E-B85D-4883-93CA-4944857F3695}"/>
+                <a16:creationId xmlns:a16="http://schemas.microsoft.com/office/drawing/2014/main" id="{4A8CCFCB-1692-429B-996D-B7DBF483769F}"/>
               </a:ext>
             </a:extLst>
           </p:cNvPr>
@@ -6499,7 +6499,7 @@
           <p:nvPr/>
         </p:nvPicPr>
         <p:blipFill>
-          <a:blip xmlns:r="http://schemas.openxmlformats.org/officeDocument/2006/relationships" xmlns:a="http://schemas.openxmlformats.org/drawingml/2006/main" r:embed="R045607847e4c4f4d"/>
+          <a:blip xmlns:r="http://schemas.openxmlformats.org/officeDocument/2006/relationships" xmlns:a="http://schemas.openxmlformats.org/drawingml/2006/main" r:embed="R5e2728741950486e"/>
           <a:srcRect xmlns:a="http://schemas.openxmlformats.org/drawingml/2006/main" l="19000" t="31000" r="2000" b="20000"/>
           <a:stretch xmlns:a="http://schemas.openxmlformats.org/drawingml/2006/main"/>
         </p:blipFill>
@@ -6518,7 +6518,7 @@
           <p:cNvPr id="6" name="">
             <a:extLst xmlns:a="http://schemas.openxmlformats.org/drawingml/2006/main">
               <a:ext uri="{FF2B5EF4-FFF2-40B4-BE49-F238E27FC236}">
-                <a16:creationId xmlns:a16="http://schemas.microsoft.com/office/drawing/2014/main" id="{3DBD09A0-3FC9-446B-A054-81DC154F544B}"/>
+                <a16:creationId xmlns:a16="http://schemas.microsoft.com/office/drawing/2014/main" id="{3790FE3A-3F4B-40DA-928A-6EC408EC4002}"/>
               </a:ext>
             </a:extLst>
           </p:cNvPr>
@@ -6584,7 +6584,7 @@
           <p:cNvPr id="7" name="">
             <a:extLst xmlns:a="http://schemas.openxmlformats.org/drawingml/2006/main">
               <a:ext uri="{FF2B5EF4-FFF2-40B4-BE49-F238E27FC236}">
-                <a16:creationId xmlns:a16="http://schemas.microsoft.com/office/drawing/2014/main" id="{FBA99525-AC12-4A13-9CE1-411F5AB88FD4}"/>
+                <a16:creationId xmlns:a16="http://schemas.microsoft.com/office/drawing/2014/main" id="{53407B95-C5BA-4BD4-9EAF-430F4BA793DD}"/>
               </a:ext>
             </a:extLst>
           </p:cNvPr>
@@ -6648,7 +6648,7 @@
     </p:spTree>
     <p:extLst>
       <p:ext uri="{BB962C8B-B14F-4D97-AF65-F5344CB8AC3E}">
-        <p14:creationId xmlns:p14="http://schemas.microsoft.com/office/powerpoint/2010/main" val="263714812"/>
+        <p14:creationId xmlns:p14="http://schemas.microsoft.com/office/powerpoint/2010/main" val="1382328587"/>
       </p:ext>
     </p:extLst>
   </p:cSld>
@@ -6679,7 +6679,7 @@
           <p:cNvPr id="10" name="">
             <a:extLst xmlns:a="http://schemas.openxmlformats.org/drawingml/2006/main">
               <a:ext uri="{FF2B5EF4-FFF2-40B4-BE49-F238E27FC236}">
-                <a16:creationId xmlns:a16="http://schemas.microsoft.com/office/drawing/2014/main" id="{CD8EA821-8F14-4DEB-994D-707066CC4A78}"/>
+                <a16:creationId xmlns:a16="http://schemas.microsoft.com/office/drawing/2014/main" id="{C2D3C7CF-991D-46A1-8630-2783A50C92BC}"/>
               </a:ext>
             </a:extLst>
           </p:cNvPr>
@@ -6745,7 +6745,7 @@
           <p:cNvPr id="2" name="">
             <a:extLst xmlns:a="http://schemas.openxmlformats.org/drawingml/2006/main">
               <a:ext uri="{FF2B5EF4-FFF2-40B4-BE49-F238E27FC236}">
-                <a16:creationId xmlns:a16="http://schemas.microsoft.com/office/drawing/2014/main" id="{324DA1EE-E9B9-454A-B96A-5A526D875088}"/>
+                <a16:creationId xmlns:a16="http://schemas.microsoft.com/office/drawing/2014/main" id="{21D25A36-1B09-4E3F-9F92-8DB41CA33B71}"/>
               </a:ext>
             </a:extLst>
           </p:cNvPr>
@@ -6834,7 +6834,7 @@
           <p:cNvPr id="3" name="">
             <a:extLst xmlns:a="http://schemas.openxmlformats.org/drawingml/2006/main">
               <a:ext uri="{FF2B5EF4-FFF2-40B4-BE49-F238E27FC236}">
-                <a16:creationId xmlns:a16="http://schemas.microsoft.com/office/drawing/2014/main" id="{E515C0CA-7E34-4640-BDDD-FFDE09329755}"/>
+                <a16:creationId xmlns:a16="http://schemas.microsoft.com/office/drawing/2014/main" id="{52E15528-83A4-4EDD-A790-A882EC27D45F}"/>
               </a:ext>
             </a:extLst>
           </p:cNvPr>
@@ -6946,7 +6946,7 @@
           <p:cNvPr id="4" name="">
             <a:extLst xmlns:a="http://schemas.openxmlformats.org/drawingml/2006/main">
               <a:ext uri="{FF2B5EF4-FFF2-40B4-BE49-F238E27FC236}">
-                <a16:creationId xmlns:a16="http://schemas.microsoft.com/office/drawing/2014/main" id="{54216F1D-EBA0-4609-825A-0E8BE245E3BF}"/>
+                <a16:creationId xmlns:a16="http://schemas.microsoft.com/office/drawing/2014/main" id="{3406146A-D752-4036-8DB6-E3637636BCD4}"/>
               </a:ext>
             </a:extLst>
           </p:cNvPr>
@@ -7012,7 +7012,7 @@
           <p:cNvPr id="5" name="">
             <a:extLst xmlns:a="http://schemas.openxmlformats.org/drawingml/2006/main">
               <a:ext uri="{FF2B5EF4-FFF2-40B4-BE49-F238E27FC236}">
-                <a16:creationId xmlns:a16="http://schemas.microsoft.com/office/drawing/2014/main" id="{8147C681-2E90-40DE-9780-AE323C458368}"/>
+                <a16:creationId xmlns:a16="http://schemas.microsoft.com/office/drawing/2014/main" id="{FEA10848-CBF5-498B-AF69-EE32354F876D}"/>
               </a:ext>
             </a:extLst>
           </p:cNvPr>
@@ -7101,7 +7101,7 @@
           <p:cNvPr id="6" name="">
             <a:extLst xmlns:a="http://schemas.openxmlformats.org/drawingml/2006/main">
               <a:ext uri="{FF2B5EF4-FFF2-40B4-BE49-F238E27FC236}">
-                <a16:creationId xmlns:a16="http://schemas.microsoft.com/office/drawing/2014/main" id="{871BED79-635D-40CA-B86E-5E51C81B5A14}"/>
+                <a16:creationId xmlns:a16="http://schemas.microsoft.com/office/drawing/2014/main" id="{FA492A7E-FCA4-4DBF-99F8-70EEC25F4729}"/>
               </a:ext>
             </a:extLst>
           </p:cNvPr>
@@ -7111,7 +7111,7 @@
           <p:nvPr/>
         </p:nvPicPr>
         <p:blipFill>
-          <a:blip xmlns:r="http://schemas.openxmlformats.org/officeDocument/2006/relationships" xmlns:a="http://schemas.openxmlformats.org/drawingml/2006/main" r:embed="R9a83b951576c413d"/>
+          <a:blip xmlns:r="http://schemas.openxmlformats.org/officeDocument/2006/relationships" xmlns:a="http://schemas.openxmlformats.org/drawingml/2006/main" r:embed="R1a83f862d30d47dd"/>
           <a:srcRect xmlns:a="http://schemas.openxmlformats.org/drawingml/2006/main" l="19800" t="37800" r="55200" b="25500"/>
           <a:stretch xmlns:a="http://schemas.openxmlformats.org/drawingml/2006/main"/>
         </p:blipFill>
@@ -7130,7 +7130,7 @@
           <p:cNvPr id="7" name="">
             <a:extLst xmlns:a="http://schemas.openxmlformats.org/drawingml/2006/main">
               <a:ext uri="{FF2B5EF4-FFF2-40B4-BE49-F238E27FC236}">
-                <a16:creationId xmlns:a16="http://schemas.microsoft.com/office/drawing/2014/main" id="{2D1F65E3-0520-4B94-9BC5-F86712560D02}"/>
+                <a16:creationId xmlns:a16="http://schemas.microsoft.com/office/drawing/2014/main" id="{6ECBDD7A-5503-4CB9-9BF0-D8ECA984F01D}"/>
               </a:ext>
             </a:extLst>
           </p:cNvPr>
@@ -7140,7 +7140,7 @@
           <p:nvPr/>
         </p:nvPicPr>
         <p:blipFill>
-          <a:blip xmlns:r="http://schemas.openxmlformats.org/officeDocument/2006/relationships" xmlns:a="http://schemas.openxmlformats.org/drawingml/2006/main" r:embed="R6c7d731d03be4cd3"/>
+          <a:blip xmlns:r="http://schemas.openxmlformats.org/officeDocument/2006/relationships" xmlns:a="http://schemas.openxmlformats.org/drawingml/2006/main" r:embed="R4e0df1223ffe4ec0"/>
           <a:srcRect xmlns:a="http://schemas.openxmlformats.org/drawingml/2006/main" l="32300" t="18600" r="32300" b="18600"/>
           <a:stretch xmlns:a="http://schemas.openxmlformats.org/drawingml/2006/main"/>
         </p:blipFill>
@@ -7159,7 +7159,7 @@
           <p:cNvPr id="8" name="">
             <a:extLst xmlns:a="http://schemas.openxmlformats.org/drawingml/2006/main">
               <a:ext uri="{FF2B5EF4-FFF2-40B4-BE49-F238E27FC236}">
-                <a16:creationId xmlns:a16="http://schemas.microsoft.com/office/drawing/2014/main" id="{8A9AB8CF-5C46-47A5-8C54-DA4333AA7F67}"/>
+                <a16:creationId xmlns:a16="http://schemas.microsoft.com/office/drawing/2014/main" id="{D12DC31A-6CE5-4A84-A70E-EF538A7B5DF4}"/>
               </a:ext>
             </a:extLst>
           </p:cNvPr>
@@ -7225,7 +7225,7 @@
           <p:cNvPr id="9" name="">
             <a:extLst xmlns:a="http://schemas.openxmlformats.org/drawingml/2006/main">
               <a:ext uri="{FF2B5EF4-FFF2-40B4-BE49-F238E27FC236}">
-                <a16:creationId xmlns:a16="http://schemas.microsoft.com/office/drawing/2014/main" id="{BB2C047E-4E38-45CA-8A08-91C2D75051B1}"/>
+                <a16:creationId xmlns:a16="http://schemas.microsoft.com/office/drawing/2014/main" id="{D975B3E6-9E47-4B18-AC6B-30DBC1C6F70F}"/>
               </a:ext>
             </a:extLst>
           </p:cNvPr>
@@ -7289,7 +7289,7 @@
     </p:spTree>
     <p:extLst>
       <p:ext uri="{BB962C8B-B14F-4D97-AF65-F5344CB8AC3E}">
-        <p14:creationId xmlns:p14="http://schemas.microsoft.com/office/powerpoint/2010/main" val="1045330279"/>
+        <p14:creationId xmlns:p14="http://schemas.microsoft.com/office/powerpoint/2010/main" val="1984151212"/>
       </p:ext>
     </p:extLst>
   </p:cSld>
@@ -7320,7 +7320,7 @@
           <p:cNvPr id="10" name="">
             <a:extLst xmlns:a="http://schemas.openxmlformats.org/drawingml/2006/main">
               <a:ext uri="{FF2B5EF4-FFF2-40B4-BE49-F238E27FC236}">
-                <a16:creationId xmlns:a16="http://schemas.microsoft.com/office/drawing/2014/main" id="{6A96A6AF-78E8-4AE6-8A10-2B6C8AD13A41}"/>
+                <a16:creationId xmlns:a16="http://schemas.microsoft.com/office/drawing/2014/main" id="{87C052A7-F04E-4E00-866C-A19A96272F57}"/>
               </a:ext>
             </a:extLst>
           </p:cNvPr>
@@ -7386,7 +7386,7 @@
           <p:cNvPr id="2" name="">
             <a:extLst xmlns:a="http://schemas.openxmlformats.org/drawingml/2006/main">
               <a:ext uri="{FF2B5EF4-FFF2-40B4-BE49-F238E27FC236}">
-                <a16:creationId xmlns:a16="http://schemas.microsoft.com/office/drawing/2014/main" id="{9D1937B4-3522-4F5F-9923-76C4CBC01216}"/>
+                <a16:creationId xmlns:a16="http://schemas.microsoft.com/office/drawing/2014/main" id="{EC6817F5-A3FE-4FEC-ABA2-A65535CDBE3C}"/>
               </a:ext>
             </a:extLst>
           </p:cNvPr>
@@ -7475,7 +7475,7 @@
           <p:cNvPr id="3" name="">
             <a:extLst xmlns:a="http://schemas.openxmlformats.org/drawingml/2006/main">
               <a:ext uri="{FF2B5EF4-FFF2-40B4-BE49-F238E27FC236}">
-                <a16:creationId xmlns:a16="http://schemas.microsoft.com/office/drawing/2014/main" id="{0DE121D7-3D61-444E-8EC7-E55D1F10024B}"/>
+                <a16:creationId xmlns:a16="http://schemas.microsoft.com/office/drawing/2014/main" id="{3499C75F-CF45-405D-B358-B2AEF587C2B5}"/>
               </a:ext>
             </a:extLst>
           </p:cNvPr>
@@ -7587,7 +7587,7 @@
           <p:cNvPr id="4" name="">
             <a:extLst xmlns:a="http://schemas.openxmlformats.org/drawingml/2006/main">
               <a:ext uri="{FF2B5EF4-FFF2-40B4-BE49-F238E27FC236}">
-                <a16:creationId xmlns:a16="http://schemas.microsoft.com/office/drawing/2014/main" id="{3FA57534-6F88-4ECF-B607-191B15F0CCC7}"/>
+                <a16:creationId xmlns:a16="http://schemas.microsoft.com/office/drawing/2014/main" id="{EBF46EFA-7FA3-41CE-B82A-4E88B7213540}"/>
               </a:ext>
             </a:extLst>
           </p:cNvPr>
@@ -7653,7 +7653,7 @@
           <p:cNvPr id="5" name="">
             <a:extLst xmlns:a="http://schemas.openxmlformats.org/drawingml/2006/main">
               <a:ext uri="{FF2B5EF4-FFF2-40B4-BE49-F238E27FC236}">
-                <a16:creationId xmlns:a16="http://schemas.microsoft.com/office/drawing/2014/main" id="{6509DE85-3BB1-4E63-BEF0-30ED6774A013}"/>
+                <a16:creationId xmlns:a16="http://schemas.microsoft.com/office/drawing/2014/main" id="{6AC6CBE7-F1A5-4A7D-B294-C4D477F2F3F8}"/>
               </a:ext>
             </a:extLst>
           </p:cNvPr>
@@ -7719,7 +7719,7 @@
           <p:cNvPr id="6" name="">
             <a:extLst xmlns:a="http://schemas.openxmlformats.org/drawingml/2006/main">
               <a:ext uri="{FF2B5EF4-FFF2-40B4-BE49-F238E27FC236}">
-                <a16:creationId xmlns:a16="http://schemas.microsoft.com/office/drawing/2014/main" id="{670C3F7A-DA3C-4E0E-B7CA-5BFC915FEF5E}"/>
+                <a16:creationId xmlns:a16="http://schemas.microsoft.com/office/drawing/2014/main" id="{EBF2616F-8EA5-4B87-82A9-C38061537654}"/>
               </a:ext>
             </a:extLst>
           </p:cNvPr>
@@ -7729,7 +7729,7 @@
           <p:nvPr/>
         </p:nvPicPr>
         <p:blipFill>
-          <a:blip xmlns:r="http://schemas.openxmlformats.org/officeDocument/2006/relationships" xmlns:a="http://schemas.openxmlformats.org/drawingml/2006/main" r:embed="R3743fd5dcf984806"/>
+          <a:blip xmlns:r="http://schemas.openxmlformats.org/officeDocument/2006/relationships" xmlns:a="http://schemas.openxmlformats.org/drawingml/2006/main" r:embed="R73c4656b773f4755"/>
           <a:srcRect xmlns:a="http://schemas.openxmlformats.org/drawingml/2006/main" l="0" t="0" r="2800" b="0"/>
           <a:stretch xmlns:a="http://schemas.openxmlformats.org/drawingml/2006/main"/>
         </p:blipFill>
@@ -7748,7 +7748,7 @@
           <p:cNvPr id="7" name="">
             <a:extLst xmlns:a="http://schemas.openxmlformats.org/drawingml/2006/main">
               <a:ext uri="{FF2B5EF4-FFF2-40B4-BE49-F238E27FC236}">
-                <a16:creationId xmlns:a16="http://schemas.microsoft.com/office/drawing/2014/main" id="{1D3DDB4A-BF1D-4C77-8512-2513CDDE45F8}"/>
+                <a16:creationId xmlns:a16="http://schemas.microsoft.com/office/drawing/2014/main" id="{FF7EB0E0-13E3-4FA7-9B96-0CA0B1802005}"/>
               </a:ext>
             </a:extLst>
           </p:cNvPr>
@@ -7758,7 +7758,7 @@
           <p:nvPr/>
         </p:nvPicPr>
         <p:blipFill>
-          <a:blip xmlns:r="http://schemas.openxmlformats.org/officeDocument/2006/relationships" xmlns:a="http://schemas.openxmlformats.org/drawingml/2006/main" r:embed="R3a857a50bcf34925"/>
+          <a:blip xmlns:r="http://schemas.openxmlformats.org/officeDocument/2006/relationships" xmlns:a="http://schemas.openxmlformats.org/drawingml/2006/main" r:embed="Rac911173ad4a484c"/>
           <a:srcRect xmlns:a="http://schemas.openxmlformats.org/drawingml/2006/main" l="0" t="0" r="2800" b="0"/>
           <a:stretch xmlns:a="http://schemas.openxmlformats.org/drawingml/2006/main"/>
         </p:blipFill>
@@ -7777,7 +7777,7 @@
           <p:cNvPr id="8" name="">
             <a:extLst xmlns:a="http://schemas.openxmlformats.org/drawingml/2006/main">
               <a:ext uri="{FF2B5EF4-FFF2-40B4-BE49-F238E27FC236}">
-                <a16:creationId xmlns:a16="http://schemas.microsoft.com/office/drawing/2014/main" id="{190E3A2E-5926-4965-9054-A2DFA1D1C624}"/>
+                <a16:creationId xmlns:a16="http://schemas.microsoft.com/office/drawing/2014/main" id="{3B84C508-2E0E-4737-B002-76724D8B20FE}"/>
               </a:ext>
             </a:extLst>
           </p:cNvPr>
@@ -7843,7 +7843,7 @@
           <p:cNvPr id="9" name="">
             <a:extLst xmlns:a="http://schemas.openxmlformats.org/drawingml/2006/main">
               <a:ext uri="{FF2B5EF4-FFF2-40B4-BE49-F238E27FC236}">
-                <a16:creationId xmlns:a16="http://schemas.microsoft.com/office/drawing/2014/main" id="{DE0FA921-FFC2-4210-8F7E-5A4474A295B8}"/>
+                <a16:creationId xmlns:a16="http://schemas.microsoft.com/office/drawing/2014/main" id="{E7F52E69-85F1-4922-A448-FD7AB02B17C2}"/>
               </a:ext>
             </a:extLst>
           </p:cNvPr>
@@ -7907,7 +7907,7 @@
     </p:spTree>
     <p:extLst>
       <p:ext uri="{BB962C8B-B14F-4D97-AF65-F5344CB8AC3E}">
-        <p14:creationId xmlns:p14="http://schemas.microsoft.com/office/powerpoint/2010/main" val="504920159"/>
+        <p14:creationId xmlns:p14="http://schemas.microsoft.com/office/powerpoint/2010/main" val="1688108160"/>
       </p:ext>
     </p:extLst>
   </p:cSld>
@@ -7938,7 +7938,7 @@
           <p:cNvPr id="11" name="">
             <a:extLst xmlns:a="http://schemas.openxmlformats.org/drawingml/2006/main">
               <a:ext uri="{FF2B5EF4-FFF2-40B4-BE49-F238E27FC236}">
-                <a16:creationId xmlns:a16="http://schemas.microsoft.com/office/drawing/2014/main" id="{C5845EC5-5F50-4E0B-A036-B83B27A086F0}"/>
+                <a16:creationId xmlns:a16="http://schemas.microsoft.com/office/drawing/2014/main" id="{710D6FAC-4BDA-4015-9152-F87EB98C15F6}"/>
               </a:ext>
             </a:extLst>
           </p:cNvPr>
@@ -8004,7 +8004,7 @@
           <p:cNvPr id="2" name="">
             <a:extLst xmlns:a="http://schemas.openxmlformats.org/drawingml/2006/main">
               <a:ext uri="{FF2B5EF4-FFF2-40B4-BE49-F238E27FC236}">
-                <a16:creationId xmlns:a16="http://schemas.microsoft.com/office/drawing/2014/main" id="{D1573BD2-3235-4C01-AB9C-386E65183A5C}"/>
+                <a16:creationId xmlns:a16="http://schemas.microsoft.com/office/drawing/2014/main" id="{368FF9FA-DB26-4855-BF39-F79D5BED523B}"/>
               </a:ext>
             </a:extLst>
           </p:cNvPr>
@@ -8014,7 +8014,7 @@
           <p:nvPr/>
         </p:nvPicPr>
         <p:blipFill>
-          <a:blip xmlns:r="http://schemas.openxmlformats.org/officeDocument/2006/relationships" xmlns:a="http://schemas.openxmlformats.org/drawingml/2006/main" r:embed="R0a37510dd7174d24"/>
+          <a:blip xmlns:r="http://schemas.openxmlformats.org/officeDocument/2006/relationships" xmlns:a="http://schemas.openxmlformats.org/drawingml/2006/main" r:embed="Rd8f8016fe840449b"/>
           <a:srcRect xmlns:a="http://schemas.openxmlformats.org/drawingml/2006/main" l="23000" t="3000" r="31000" b="3000"/>
           <a:stretch xmlns:a="http://schemas.openxmlformats.org/drawingml/2006/main"/>
         </p:blipFill>
@@ -8033,7 +8033,7 @@
           <p:cNvPr id="3" name="">
             <a:extLst xmlns:a="http://schemas.openxmlformats.org/drawingml/2006/main">
               <a:ext uri="{FF2B5EF4-FFF2-40B4-BE49-F238E27FC236}">
-                <a16:creationId xmlns:a16="http://schemas.microsoft.com/office/drawing/2014/main" id="{41953B7C-2F45-43DA-993D-5EF2E95AB240}"/>
+                <a16:creationId xmlns:a16="http://schemas.microsoft.com/office/drawing/2014/main" id="{A2E1115E-097D-47F2-A375-85A860A22925}"/>
               </a:ext>
             </a:extLst>
           </p:cNvPr>
@@ -8099,7 +8099,7 @@
           <p:cNvPr id="4" name="">
             <a:extLst xmlns:a="http://schemas.openxmlformats.org/drawingml/2006/main">
               <a:ext uri="{FF2B5EF4-FFF2-40B4-BE49-F238E27FC236}">
-                <a16:creationId xmlns:a16="http://schemas.microsoft.com/office/drawing/2014/main" id="{2ED31B1E-A1E7-489A-BB4B-6885A3F04ECF}"/>
+                <a16:creationId xmlns:a16="http://schemas.microsoft.com/office/drawing/2014/main" id="{1C6BDFCC-4163-47D5-AFFE-0B9D86862FE4}"/>
               </a:ext>
             </a:extLst>
           </p:cNvPr>
@@ -8211,7 +8211,7 @@
           <p:cNvPr id="5" name="">
             <a:extLst xmlns:a="http://schemas.openxmlformats.org/drawingml/2006/main">
               <a:ext uri="{FF2B5EF4-FFF2-40B4-BE49-F238E27FC236}">
-                <a16:creationId xmlns:a16="http://schemas.microsoft.com/office/drawing/2014/main" id="{D63BC456-012E-4ADD-AEC3-49E7F60246DC}"/>
+                <a16:creationId xmlns:a16="http://schemas.microsoft.com/office/drawing/2014/main" id="{67FC295F-172B-4833-9811-ED2541DB451D}"/>
               </a:ext>
             </a:extLst>
           </p:cNvPr>
@@ -8277,7 +8277,7 @@
           <p:cNvPr id="6" name="">
             <a:extLst xmlns:a="http://schemas.openxmlformats.org/drawingml/2006/main">
               <a:ext uri="{FF2B5EF4-FFF2-40B4-BE49-F238E27FC236}">
-                <a16:creationId xmlns:a16="http://schemas.microsoft.com/office/drawing/2014/main" id="{36729BA5-B31E-4563-B111-37A174FEB01D}"/>
+                <a16:creationId xmlns:a16="http://schemas.microsoft.com/office/drawing/2014/main" id="{40524874-047E-4016-9992-0ABBF771E054}"/>
               </a:ext>
             </a:extLst>
           </p:cNvPr>
@@ -8343,7 +8343,7 @@
           <p:cNvPr id="7" name="">
             <a:extLst xmlns:a="http://schemas.openxmlformats.org/drawingml/2006/main">
               <a:ext uri="{FF2B5EF4-FFF2-40B4-BE49-F238E27FC236}">
-                <a16:creationId xmlns:a16="http://schemas.microsoft.com/office/drawing/2014/main" id="{8D404B41-702E-4BF1-A382-BC4CE420C65D}"/>
+                <a16:creationId xmlns:a16="http://schemas.microsoft.com/office/drawing/2014/main" id="{94AAE4B0-9E40-43ED-A466-AA9B3E7407F7}"/>
               </a:ext>
             </a:extLst>
           </p:cNvPr>
@@ -8409,7 +8409,7 @@
           <p:cNvPr id="8" name="">
             <a:extLst xmlns:a="http://schemas.openxmlformats.org/drawingml/2006/main">
               <a:ext uri="{FF2B5EF4-FFF2-40B4-BE49-F238E27FC236}">
-                <a16:creationId xmlns:a16="http://schemas.microsoft.com/office/drawing/2014/main" id="{5AFE2A77-FDD2-465C-9018-A76AF945521E}"/>
+                <a16:creationId xmlns:a16="http://schemas.microsoft.com/office/drawing/2014/main" id="{45B50B12-F804-4D92-8D03-4981C2F96D06}"/>
               </a:ext>
             </a:extLst>
           </p:cNvPr>
@@ -8498,7 +8498,7 @@
           <p:cNvPr id="9" name="">
             <a:extLst xmlns:a="http://schemas.openxmlformats.org/drawingml/2006/main">
               <a:ext uri="{FF2B5EF4-FFF2-40B4-BE49-F238E27FC236}">
-                <a16:creationId xmlns:a16="http://schemas.microsoft.com/office/drawing/2014/main" id="{D57D28EC-A559-4D97-B1DD-2388E6EA4BF1}"/>
+                <a16:creationId xmlns:a16="http://schemas.microsoft.com/office/drawing/2014/main" id="{956399EC-03D0-40C6-9C6E-0C58216D30D0}"/>
               </a:ext>
             </a:extLst>
           </p:cNvPr>
@@ -8587,7 +8587,7 @@
           <p:cNvPr id="10" name="">
             <a:extLst xmlns:a="http://schemas.openxmlformats.org/drawingml/2006/main">
               <a:ext uri="{FF2B5EF4-FFF2-40B4-BE49-F238E27FC236}">
-                <a16:creationId xmlns:a16="http://schemas.microsoft.com/office/drawing/2014/main" id="{B1BBF0F0-5172-4BBA-929A-9FBCA7FD6BE7}"/>
+                <a16:creationId xmlns:a16="http://schemas.microsoft.com/office/drawing/2014/main" id="{033D2DAE-3C4E-440C-8A8E-2AB9BBAEE98A}"/>
               </a:ext>
             </a:extLst>
           </p:cNvPr>
@@ -8651,7 +8651,7 @@
     </p:spTree>
     <p:extLst>
       <p:ext uri="{BB962C8B-B14F-4D97-AF65-F5344CB8AC3E}">
-        <p14:creationId xmlns:p14="http://schemas.microsoft.com/office/powerpoint/2010/main" val="1011864631"/>
+        <p14:creationId xmlns:p14="http://schemas.microsoft.com/office/powerpoint/2010/main" val="331491586"/>
       </p:ext>
     </p:extLst>
   </p:cSld>
@@ -8682,7 +8682,7 @@
           <p:cNvPr id="9" name="">
             <a:extLst xmlns:a="http://schemas.openxmlformats.org/drawingml/2006/main">
               <a:ext uri="{FF2B5EF4-FFF2-40B4-BE49-F238E27FC236}">
-                <a16:creationId xmlns:a16="http://schemas.microsoft.com/office/drawing/2014/main" id="{0BA9FE83-C225-48E0-9E19-E8A182D9E7AD}"/>
+                <a16:creationId xmlns:a16="http://schemas.microsoft.com/office/drawing/2014/main" id="{E2427133-5808-41E6-ACBB-D404FDB71CA8}"/>
               </a:ext>
             </a:extLst>
           </p:cNvPr>
@@ -8748,7 +8748,7 @@
           <p:cNvPr id="2" name="">
             <a:extLst xmlns:a="http://schemas.openxmlformats.org/drawingml/2006/main">
               <a:ext uri="{FF2B5EF4-FFF2-40B4-BE49-F238E27FC236}">
-                <a16:creationId xmlns:a16="http://schemas.microsoft.com/office/drawing/2014/main" id="{63D77279-AE22-4134-B229-F0A6768A18E9}"/>
+                <a16:creationId xmlns:a16="http://schemas.microsoft.com/office/drawing/2014/main" id="{D3220A09-5583-4C33-8391-F4493276A7CB}"/>
               </a:ext>
             </a:extLst>
           </p:cNvPr>
@@ -8837,7 +8837,7 @@
           <p:cNvPr id="3" name="">
             <a:extLst xmlns:a="http://schemas.openxmlformats.org/drawingml/2006/main">
               <a:ext uri="{FF2B5EF4-FFF2-40B4-BE49-F238E27FC236}">
-                <a16:creationId xmlns:a16="http://schemas.microsoft.com/office/drawing/2014/main" id="{0F14D70C-376A-4B36-B0F1-81E4B0DD68BC}"/>
+                <a16:creationId xmlns:a16="http://schemas.microsoft.com/office/drawing/2014/main" id="{1FD5BB65-17E0-4C08-A5DD-DF84FBE6E00D}"/>
               </a:ext>
             </a:extLst>
           </p:cNvPr>
@@ -8903,7 +8903,7 @@
           <p:cNvPr id="4" name="">
             <a:extLst xmlns:a="http://schemas.openxmlformats.org/drawingml/2006/main">
               <a:ext uri="{FF2B5EF4-FFF2-40B4-BE49-F238E27FC236}">
-                <a16:creationId xmlns:a16="http://schemas.microsoft.com/office/drawing/2014/main" id="{3203F631-11AA-4F87-B41D-CFE83D0F9DA7}"/>
+                <a16:creationId xmlns:a16="http://schemas.microsoft.com/office/drawing/2014/main" id="{ACA59FCC-CE3C-4ED2-98F7-75894E348F01}"/>
               </a:ext>
             </a:extLst>
           </p:cNvPr>
@@ -8969,7 +8969,7 @@
           <p:cNvPr id="5" name="">
             <a:extLst xmlns:a="http://schemas.openxmlformats.org/drawingml/2006/main">
               <a:ext uri="{FF2B5EF4-FFF2-40B4-BE49-F238E27FC236}">
-                <a16:creationId xmlns:a16="http://schemas.microsoft.com/office/drawing/2014/main" id="{D81B8CCB-408B-424B-95C5-A95C3A19316D}"/>
+                <a16:creationId xmlns:a16="http://schemas.microsoft.com/office/drawing/2014/main" id="{7EC1A6B8-7872-4F32-8E90-00A35F58ED0F}"/>
               </a:ext>
             </a:extLst>
           </p:cNvPr>
@@ -9058,7 +9058,7 @@
           <p:cNvPr id="6" name="">
             <a:extLst xmlns:a="http://schemas.openxmlformats.org/drawingml/2006/main">
               <a:ext uri="{FF2B5EF4-FFF2-40B4-BE49-F238E27FC236}">
-                <a16:creationId xmlns:a16="http://schemas.microsoft.com/office/drawing/2014/main" id="{702C7146-0989-4CB3-9E4D-40F2B9D9824E}"/>
+                <a16:creationId xmlns:a16="http://schemas.microsoft.com/office/drawing/2014/main" id="{5559EB4C-2C23-4B07-B2E4-26760DBCDF1E}"/>
               </a:ext>
             </a:extLst>
           </p:cNvPr>
@@ -9124,7 +9124,7 @@
           <p:cNvPr id="7" name="">
             <a:extLst xmlns:a="http://schemas.openxmlformats.org/drawingml/2006/main">
               <a:ext uri="{FF2B5EF4-FFF2-40B4-BE49-F238E27FC236}">
-                <a16:creationId xmlns:a16="http://schemas.microsoft.com/office/drawing/2014/main" id="{E9248B09-8C17-4F1B-80D7-5065CF09B0F4}"/>
+                <a16:creationId xmlns:a16="http://schemas.microsoft.com/office/drawing/2014/main" id="{B9C20843-5F73-447B-AD6C-1D188F420CB6}"/>
               </a:ext>
             </a:extLst>
           </p:cNvPr>
@@ -9190,7 +9190,7 @@
           <p:cNvPr id="8" name="">
             <a:extLst xmlns:a="http://schemas.openxmlformats.org/drawingml/2006/main">
               <a:ext uri="{FF2B5EF4-FFF2-40B4-BE49-F238E27FC236}">
-                <a16:creationId xmlns:a16="http://schemas.microsoft.com/office/drawing/2014/main" id="{10BB60DA-A93C-46A3-A016-83EBF55D1CD5}"/>
+                <a16:creationId xmlns:a16="http://schemas.microsoft.com/office/drawing/2014/main" id="{1CA702C1-526F-48AC-9B69-1E4225C302A6}"/>
               </a:ext>
             </a:extLst>
           </p:cNvPr>
@@ -9254,7 +9254,7 @@
     </p:spTree>
     <p:extLst>
       <p:ext uri="{BB962C8B-B14F-4D97-AF65-F5344CB8AC3E}">
-        <p14:creationId xmlns:p14="http://schemas.microsoft.com/office/powerpoint/2010/main" val="708287504"/>
+        <p14:creationId xmlns:p14="http://schemas.microsoft.com/office/powerpoint/2010/main" val="2031090203"/>
       </p:ext>
     </p:extLst>
   </p:cSld>

</xml_diff>